<commit_message>
Aula oficial: unifica deck principal + apendice de satelites (86 slides, numeracao continua, remissoes)
Co-Authored-By: Claude Fable 5 <noreply@anthropic.com>
Claude-Session: https://claude.ai/code/session_018axhg2YPoGkj2YuJKRU4fe
</commit_message>
<xml_diff>
--- a/aulas/desenvolvimento-normal-2-anos-puberdade/deck/Desenvolvimento-normal-2a-puberdade_PsiquiatriaPratica.pptx
+++ b/aulas/desenvolvimento-normal-2-anos-puberdade/deck/Desenvolvimento-normal-2a-puberdade_PsiquiatriaPratica.pptx
@@ -1969,7 +1969,7 @@
           <a:p>
             <a:r>
               <a:rPr lang="en-US" dirty="0"/>
-              <a:t>Preditores: faz de conta compartilhado, memória de trabalho e LINGUAGEM (limiar linguístico para passar em crença falsa). Velocidade de aquisição prediz habilidade social futura.</a:t>
+              <a:t>Preditores: faz de conta compartilhado, memória de trabalho e LINGUAGEM (limiar linguístico para passar em crença falsa). Velocidade de aquisição prediz habilidade social futura. Nuance no apêndice C: a transição é gradual (Wellman), sem idade-muro.</a:t>
             </a:r>
             <a:endParaRPr lang="en-US" dirty="0"/>
           </a:p>
@@ -3377,7 +3377,7 @@
           <a:p>
             <a:r>
               <a:rPr lang="en-US" dirty="0"/>
-              <a:t>[APOSTA] ANTES de mostrar: 'por que a fila do TDAH no ambulatório começa aos 6, e não aos 4?'. Colher palpites, revelar. Frase para levar: a demanda subiu antes de o freio ficar pronto. O freio já era imaturo aos 4; aos 4 ninguém precisava dele.</a:t>
+              <a:t>[APOSTA] ANTES de mostrar: 'por que a fila do TDAH no ambulatório começa aos 6, e não aos 4?'. Colher palpites, revelar. Frase para levar: a demanda subiu antes de o freio ficar pronto. O freio já era imaturo aos 4; aos 4 ninguém precisava dele. Duas ressalvas de fala (detalhadas no apêndice B): o vão explica QUANDO chega à consulta, não O QUE o TDAH é; e o mesmo vão produz falsos positivos (efeito de idade relativa).</a:t>
             </a:r>
             <a:endParaRPr lang="en-US" dirty="0"/>
           </a:p>
@@ -5489,7 +5489,7 @@
           <a:p>
             <a:r>
               <a:rPr lang="en-US" dirty="0"/>
-              <a:t>Fim. Agradecer e apontar o documento de apoio.</a:t>
+              <a:t>Fim. Agradecer e apontar o documento de apoio. Perguntas da plateia: saltar para o apêndice D (respostas prontas) quando houver slide correspondente.</a:t>
             </a:r>
             <a:endParaRPr lang="en-US" dirty="0"/>
           </a:p>

</xml_diff>